<commit_message>
chore: add RAG diagrams, HUD display asset, pitch deck updates, generator scripts
</commit_message>
<xml_diff>
--- a/pitch/aeogeo_pitch_deck.pptx
+++ b/pitch/aeogeo_pitch_deck.pptx
@@ -3216,7 +3216,7 @@
                 </a:solidFill>
                 <a:latin typeface="Inter"/>
               </a:rPr>
-              <a:t>AEOGEO</a:t>
+              <a:t>AEOGEO  ·  YogaQ</a:t>
             </a:r>
           </a:p>
         </p:txBody>
@@ -3229,7 +3229,7 @@
         </p:nvSpPr>
         <p:spPr>
           <a:xfrm>
-            <a:off x="731520" y="2011680"/>
+            <a:off x="731520" y="1828800"/>
             <a:ext cx="10515600" cy="1828800"/>
           </a:xfrm>
           <a:prstGeom prst="rect">
@@ -3245,13 +3245,25 @@
           <a:p>
             <a:pPr algn="l"/>
             <a:r>
-              <a:rPr sz="6400" b="1">
+              <a:rPr sz="5200" b="1">
                 <a:solidFill>
                   <a:srgbClr val="E6EDF7"/>
                 </a:solidFill>
                 <a:latin typeface="Inter"/>
               </a:rPr>
-              <a:t>The AI yoga curator</a:t>
+              <a:t>The Deep-Tech RAG Engine</a:t>
+            </a:r>
+          </a:p>
+          <a:p>
+            <a:pPr algn="l"/>
+            <a:r>
+              <a:rPr sz="5200" b="1">
+                <a:solidFill>
+                  <a:srgbClr val="E6EDF7"/>
+                </a:solidFill>
+                <a:latin typeface="Inter"/>
+              </a:rPr>
+              <a:t>for Safety-First Yoga Matching</a:t>
             </a:r>
           </a:p>
         </p:txBody>
@@ -3264,41 +3276,41 @@
         </p:nvSpPr>
         <p:spPr>
           <a:xfrm>
-            <a:off x="731520" y="3291840"/>
-            <a:ext cx="10515600" cy="1463040"/>
-          </a:xfrm>
-          <a:prstGeom prst="rect">
-            <a:avLst/>
-          </a:prstGeom>
-          <a:noFill/>
-        </p:spPr>
-        <p:txBody>
-          <a:bodyPr wrap="square" anchor="t" lIns="0" rIns="0" tIns="0" bIns="0">
-            <a:spAutoFit/>
-          </a:bodyPr>
-          <a:lstStyle/>
-          <a:p>
-            <a:pPr algn="l"/>
-            <a:r>
-              <a:rPr sz="2200" b="0">
+            <a:off x="731520" y="3657600"/>
+            <a:ext cx="10515600" cy="1280160"/>
+          </a:xfrm>
+          <a:prstGeom prst="rect">
+            <a:avLst/>
+          </a:prstGeom>
+          <a:noFill/>
+        </p:spPr>
+        <p:txBody>
+          <a:bodyPr wrap="square" anchor="t" lIns="0" rIns="0" tIns="0" bIns="0">
+            <a:spAutoFit/>
+          </a:bodyPr>
+          <a:lstStyle/>
+          <a:p>
+            <a:pPr algn="l"/>
+            <a:r>
+              <a:rPr sz="1900" b="0">
                 <a:solidFill>
                   <a:srgbClr val="8B97AA"/>
                 </a:solidFill>
                 <a:latin typeface="Inter"/>
               </a:rPr>
-              <a:t>Personalized class matching for every body —</a:t>
-            </a:r>
-          </a:p>
-          <a:p>
-            <a:pPr algn="l"/>
-            <a:r>
-              <a:rPr sz="2200" b="0">
+              <a:t>20년 전문가 지식을 500ms 이내에 처리하는 고정밀 AI 처방(Prescription) 엔진 —</a:t>
+            </a:r>
+          </a:p>
+          <a:p>
+            <a:pPr algn="l"/>
+            <a:r>
+              <a:rPr sz="1900" b="0">
                 <a:solidFill>
                   <a:srgbClr val="8B97AA"/>
                 </a:solidFill>
                 <a:latin typeface="Inter"/>
               </a:rPr>
-              <a:t>engineered to be cited by the AI assistants people now ask.</a:t>
+              <a:t>일반 생성형 AI의 할루시네이션과 안전성 결여를 넥어서는 B2B2C 플랫폼.</a:t>
             </a:r>
           </a:p>
         </p:txBody>
@@ -3311,8 +3323,8 @@
         </p:nvSpPr>
         <p:spPr>
           <a:xfrm>
-            <a:off x="731520" y="4937760"/>
-            <a:ext cx="1188720" cy="292608"/>
+            <a:off x="731520" y="5029200"/>
+            <a:ext cx="1737360" cy="292608"/>
           </a:xfrm>
           <a:prstGeom prst="roundRect">
             <a:avLst>
@@ -3352,7 +3364,7 @@
                 </a:solidFill>
                 <a:latin typeface="Inter"/>
               </a:rPr>
-              <a:t>INVESTOR DECK · v1</a:t>
+              <a:t>INVESTOR DECK · v2  ·  IR 2026</a:t>
             </a:r>
           </a:p>
         </p:txBody>
@@ -3365,8 +3377,8 @@
         </p:nvSpPr>
         <p:spPr>
           <a:xfrm>
-            <a:off x="2286000" y="4937760"/>
-            <a:ext cx="777240" cy="292608"/>
+            <a:off x="2926080" y="5029200"/>
+            <a:ext cx="1600200" cy="292608"/>
           </a:xfrm>
           <a:prstGeom prst="roundRect">
             <a:avLst>
@@ -3406,14 +3418,68 @@
                 </a:solidFill>
                 <a:latin typeface="Inter"/>
               </a:rPr>
-              <a:t>AEO + GEO</a:t>
-            </a:r>
-          </a:p>
-        </p:txBody>
-      </p:sp>
-      <p:sp>
-        <p:nvSpPr>
-          <p:cNvPr id="9" name="TextBox 8"/>
+              <a:t>Deep-Tech AI · RAG Pipeline</a:t>
+            </a:r>
+          </a:p>
+        </p:txBody>
+      </p:sp>
+      <p:sp>
+        <p:nvSpPr>
+          <p:cNvPr id="9" name="Rounded Rectangle 8"/>
+          <p:cNvSpPr/>
+          <p:nvPr/>
+        </p:nvSpPr>
+        <p:spPr>
+          <a:xfrm>
+            <a:off x="6035040" y="5029200"/>
+            <a:ext cx="1188720" cy="292608"/>
+          </a:xfrm>
+          <a:prstGeom prst="roundRect">
+            <a:avLst>
+              <a:gd name="adj" fmla="val 50000"/>
+            </a:avLst>
+          </a:prstGeom>
+          <a:solidFill>
+            <a:srgbClr val="161F33"/>
+          </a:solidFill>
+          <a:ln>
+            <a:noFill/>
+          </a:ln>
+        </p:spPr>
+        <p:style>
+          <a:lnRef idx="1">
+            <a:schemeClr val="accent1"/>
+          </a:lnRef>
+          <a:fillRef idx="3">
+            <a:schemeClr val="accent1"/>
+          </a:fillRef>
+          <a:effectRef idx="2">
+            <a:schemeClr val="accent1"/>
+          </a:effectRef>
+          <a:fontRef idx="minor">
+            <a:schemeClr val="lt1"/>
+          </a:fontRef>
+        </p:style>
+        <p:txBody>
+          <a:bodyPr rtlCol="0" anchor="ctr" lIns="109728" rIns="109728" tIns="0" bIns="0"/>
+          <a:lstStyle/>
+          <a:p>
+            <a:pPr algn="ctr"/>
+            <a:r>
+              <a:rPr sz="1000" b="1">
+                <a:solidFill>
+                  <a:srgbClr val="3DD9C2"/>
+                </a:solidFill>
+                <a:latin typeface="Inter"/>
+              </a:rPr>
+              <a:t>AEO + Global Scale</a:t>
+            </a:r>
+          </a:p>
+        </p:txBody>
+      </p:sp>
+      <p:sp>
+        <p:nvSpPr>
+          <p:cNvPr id="10" name="TextBox 9"/>
           <p:cNvSpPr txBox="1"/>
           <p:nvPr/>
         </p:nvSpPr>
@@ -3615,7 +3681,7 @@
                 </a:solidFill>
                 <a:latin typeface="Inter"/>
               </a:rPr>
-              <a:t>Land studios → harvest queries → power consumer growth.</a:t>
+              <a:t>국내 스튜디오 인덱싱 → 글로벌 AI 검색 생태계 진입</a:t>
             </a:r>
           </a:p>
         </p:txBody>
@@ -3726,13 +3792,13 @@
           <a:p>
             <a:pPr algn="l"/>
             <a:r>
-              <a:rPr sz="2200" b="1">
+              <a:rPr sz="2000" b="1">
                 <a:solidFill>
                   <a:srgbClr val="E6EDF7"/>
                 </a:solidFill>
                 <a:latin typeface="Inter"/>
               </a:rPr>
-              <a:t>Land</a:t>
+              <a:t>Land (Korea)</a:t>
             </a:r>
           </a:p>
         </p:txBody>
@@ -3804,13 +3870,25 @@
           <a:p>
             <a:pPr algn="l"/>
             <a:r>
-              <a:rPr sz="1200" b="0">
+              <a:rPr sz="1300" b="0">
                 <a:solidFill>
                   <a:srgbClr val="8B97AA"/>
                 </a:solidFill>
                 <a:latin typeface="Inter"/>
               </a:rPr>
-              <a:t>Free onboarding for the first 50 Seoul studios. We do the AEO setup.</a:t>
+              <a:t>서울 50개 스튜디오 무료 온보딩.</a:t>
+            </a:r>
+          </a:p>
+          <a:p>
+            <a:pPr algn="l"/>
+            <a:r>
+              <a:rPr sz="1300" b="0">
+                <a:solidFill>
+                  <a:srgbClr val="8B97AA"/>
+                </a:solidFill>
+                <a:latin typeface="Inter"/>
+              </a:rPr>
+              <a:t>AEO JSON-LD 세팅 대행.</a:t>
             </a:r>
           </a:p>
         </p:txBody>
@@ -3921,13 +3999,13 @@
           <a:p>
             <a:pPr algn="l"/>
             <a:r>
-              <a:rPr sz="2200" b="1">
+              <a:rPr sz="2000" b="1">
                 <a:solidFill>
                   <a:srgbClr val="E6EDF7"/>
                 </a:solidFill>
                 <a:latin typeface="Inter"/>
               </a:rPr>
-              <a:t>Index</a:t>
+              <a:t>Index (AEO)</a:t>
             </a:r>
           </a:p>
         </p:txBody>
@@ -3999,13 +4077,25 @@
           <a:p>
             <a:pPr algn="l"/>
             <a:r>
-              <a:rPr sz="1200" b="0">
+              <a:rPr sz="1300" b="0">
                 <a:solidFill>
                   <a:srgbClr val="8B97AA"/>
                 </a:solidFill>
                 <a:latin typeface="Inter"/>
               </a:rPr>
-              <a:t>Their classes get JSON-LD published; AI assistants start citing them.</a:t>
+              <a:t>Google AI Overviews · Naver Cue</a:t>
+            </a:r>
+          </a:p>
+          <a:p>
+            <a:pPr algn="l"/>
+            <a:r>
+              <a:rPr sz="1300" b="0">
+                <a:solidFill>
+                  <a:srgbClr val="8B97AA"/>
+                </a:solidFill>
+                <a:latin typeface="Inter"/>
+              </a:rPr>
+              <a:t>인덱싱 시작 → AI 어시스턴트 인용.</a:t>
             </a:r>
           </a:p>
         </p:txBody>
@@ -4116,13 +4206,13 @@
           <a:p>
             <a:pPr algn="l"/>
             <a:r>
-              <a:rPr sz="2200" b="1">
+              <a:rPr sz="2000" b="1">
                 <a:solidFill>
                   <a:srgbClr val="E6EDF7"/>
                 </a:solidFill>
                 <a:latin typeface="Inter"/>
               </a:rPr>
-              <a:t>Match</a:t>
+              <a:t>Match (B2C)</a:t>
             </a:r>
           </a:p>
         </p:txBody>
@@ -4194,13 +4284,25 @@
           <a:p>
             <a:pPr algn="l"/>
             <a:r>
-              <a:rPr sz="1200" b="0">
+              <a:rPr sz="1300" b="0">
                 <a:solidFill>
                   <a:srgbClr val="8B97AA"/>
                 </a:solidFill>
                 <a:latin typeface="Inter"/>
               </a:rPr>
-              <a:t>Practitioners arrive via AI-driven discovery + organic search.</a:t>
+              <a:t>AI 디스커버리로 수련자 유입.</a:t>
+            </a:r>
+          </a:p>
+          <a:p>
+            <a:pPr algn="l"/>
+            <a:r>
+              <a:rPr sz="1300" b="0">
+                <a:solidFill>
+                  <a:srgbClr val="8B97AA"/>
+                </a:solidFill>
+                <a:latin typeface="Inter"/>
+              </a:rPr>
+              <a:t>Personalized 매칭 플랜 전환.</a:t>
             </a:r>
           </a:p>
         </p:txBody>
@@ -4311,13 +4413,13 @@
           <a:p>
             <a:pPr algn="l"/>
             <a:r>
-              <a:rPr sz="2200" b="1">
+              <a:rPr sz="2000" b="1">
                 <a:solidFill>
                   <a:srgbClr val="E6EDF7"/>
                 </a:solidFill>
                 <a:latin typeface="Inter"/>
               </a:rPr>
-              <a:t>Subscribe</a:t>
+              <a:t>Scale (Global)</a:t>
             </a:r>
           </a:p>
         </p:txBody>
@@ -4389,13 +4491,25 @@
           <a:p>
             <a:pPr algn="l"/>
             <a:r>
-              <a:rPr sz="1200" b="0">
+              <a:rPr sz="1300" b="0">
                 <a:solidFill>
                   <a:srgbClr val="8B97AA"/>
                 </a:solidFill>
                 <a:latin typeface="Inter"/>
               </a:rPr>
-              <a:t>Convert practitioners into ₩9,900/mo plans. Studios upgrade to paid.</a:t>
+              <a:t>Perplexity · ChatGPT · SGE 피드</a:t>
+            </a:r>
+          </a:p>
+          <a:p>
+            <a:pPr algn="l"/>
+            <a:r>
+              <a:rPr sz="1300" b="0">
+                <a:solidFill>
+                  <a:srgbClr val="8B97AA"/>
+                </a:solidFill>
+                <a:latin typeface="Inter"/>
+              </a:rPr>
+              <a:t>확장 → 일본 · 동남아 · 북미.</a:t>
             </a:r>
           </a:p>
         </p:txBody>
@@ -5947,7 +6061,7 @@
         </p:nvSpPr>
         <p:spPr>
           <a:xfrm>
-            <a:off x="731520" y="2194560"/>
+            <a:off x="731520" y="1828800"/>
             <a:ext cx="10972800" cy="1828800"/>
           </a:xfrm>
           <a:prstGeom prst="rect">
@@ -5969,7 +6083,7 @@
                 </a:solidFill>
                 <a:latin typeface="Inter"/>
               </a:rPr>
-              <a:t>Let's build the AI yoga curator.</a:t>
+              <a:t>예측이 아니라 처방.</a:t>
             </a:r>
           </a:p>
         </p:txBody>
@@ -5982,7 +6096,42 @@
         </p:nvSpPr>
         <p:spPr>
           <a:xfrm>
-            <a:off x="731520" y="3840480"/>
+            <a:off x="731520" y="3474720"/>
+            <a:ext cx="10972800" cy="1097280"/>
+          </a:xfrm>
+          <a:prstGeom prst="rect">
+            <a:avLst/>
+          </a:prstGeom>
+          <a:noFill/>
+        </p:spPr>
+        <p:txBody>
+          <a:bodyPr wrap="square" anchor="t" lIns="0" rIns="0" tIns="0" bIns="0">
+            <a:spAutoFit/>
+          </a:bodyPr>
+          <a:lstStyle/>
+          <a:p>
+            <a:pPr algn="l"/>
+            <a:r>
+              <a:rPr sz="2400" b="0">
+                <a:solidFill>
+                  <a:srgbClr val="3DD9C2"/>
+                </a:solidFill>
+                <a:latin typeface="Inter"/>
+              </a:rPr>
+              <a:t>AI 검색 시대의 웰니스 플랫폼 표준을 선도하겠습니다.</a:t>
+            </a:r>
+          </a:p>
+        </p:txBody>
+      </p:sp>
+      <p:sp>
+        <p:nvSpPr>
+          <p:cNvPr id="6" name="TextBox 5"/>
+          <p:cNvSpPr txBox="1"/>
+          <p:nvPr/>
+        </p:nvSpPr>
+        <p:spPr>
+          <a:xfrm>
+            <a:off x="731520" y="4572000"/>
             <a:ext cx="10972800" cy="914400"/>
           </a:xfrm>
           <a:prstGeom prst="rect">
@@ -5998,56 +6147,171 @@
           <a:p>
             <a:pPr algn="l"/>
             <a:r>
-              <a:rPr sz="2800" b="0">
+              <a:rPr sz="1800" b="0">
+                <a:solidFill>
+                  <a:srgbClr val="8B97AA"/>
+                </a:solidFill>
+                <a:latin typeface="Inter"/>
+              </a:rPr>
+              <a:t>글로벌 웰닁스 시장의 새로운 발견 엔진 — Safety-First AI Curation.</a:t>
+            </a:r>
+          </a:p>
+        </p:txBody>
+      </p:sp>
+      <p:sp>
+        <p:nvSpPr>
+          <p:cNvPr id="7" name="Rounded Rectangle 6"/>
+          <p:cNvSpPr/>
+          <p:nvPr/>
+        </p:nvSpPr>
+        <p:spPr>
+          <a:xfrm>
+            <a:off x="731520" y="5577840"/>
+            <a:ext cx="1463040" cy="292608"/>
+          </a:xfrm>
+          <a:prstGeom prst="roundRect">
+            <a:avLst>
+              <a:gd name="adj" fmla="val 50000"/>
+            </a:avLst>
+          </a:prstGeom>
+          <a:solidFill>
+            <a:srgbClr val="161F33"/>
+          </a:solidFill>
+          <a:ln>
+            <a:noFill/>
+          </a:ln>
+        </p:spPr>
+        <p:style>
+          <a:lnRef idx="1">
+            <a:schemeClr val="accent1"/>
+          </a:lnRef>
+          <a:fillRef idx="3">
+            <a:schemeClr val="accent1"/>
+          </a:fillRef>
+          <a:effectRef idx="2">
+            <a:schemeClr val="accent1"/>
+          </a:effectRef>
+          <a:fontRef idx="minor">
+            <a:schemeClr val="lt1"/>
+          </a:fontRef>
+        </p:style>
+        <p:txBody>
+          <a:bodyPr rtlCol="0" anchor="ctr" lIns="109728" rIns="109728" tIns="0" bIns="0"/>
+          <a:lstStyle/>
+          <a:p>
+            <a:pPr algn="ctr"/>
+            <a:r>
+              <a:rPr sz="1000" b="1">
                 <a:solidFill>
                   <a:srgbClr val="3DD9C2"/>
                 </a:solidFill>
                 <a:latin typeface="Inter"/>
               </a:rPr>
-              <a:t>Thank you.</a:t>
-            </a:r>
-          </a:p>
-        </p:txBody>
-      </p:sp>
-      <p:sp>
-        <p:nvSpPr>
-          <p:cNvPr id="6" name="TextBox 5"/>
-          <p:cNvSpPr txBox="1"/>
-          <p:nvPr/>
-        </p:nvSpPr>
-        <p:spPr>
-          <a:xfrm>
-            <a:off x="731520" y="5120640"/>
-            <a:ext cx="10972800" cy="1097280"/>
-          </a:xfrm>
-          <a:prstGeom prst="rect">
-            <a:avLst/>
-          </a:prstGeom>
-          <a:noFill/>
-        </p:spPr>
-        <p:txBody>
-          <a:bodyPr wrap="square" anchor="t" lIns="0" rIns="0" tIns="0" bIns="0">
-            <a:spAutoFit/>
-          </a:bodyPr>
-          <a:lstStyle/>
-          <a:p>
-            <a:pPr algn="l"/>
-            <a:r>
-              <a:rPr sz="1400" b="0">
-                <a:solidFill>
-                  <a:srgbClr val="8B97AA"/>
-                </a:solidFill>
-                <a:latin typeface="Inter"/>
-              </a:rPr>
-              <a:t>yogaman.club  ·  match.yogaman.club  ·  elbee.yogaman.club</a:t>
-            </a:r>
-          </a:p>
-          <a:p>
-            <a:pPr algn="l"/>
-            <a:r>
-              <a:rPr sz="1400" b="0">
-                <a:solidFill>
-                  <a:srgbClr val="8B97AA"/>
+              <a:t>github.com/aiegoo/aeogeo</a:t>
+            </a:r>
+          </a:p>
+        </p:txBody>
+      </p:sp>
+      <p:sp>
+        <p:nvSpPr>
+          <p:cNvPr id="8" name="Rounded Rectangle 7"/>
+          <p:cNvSpPr/>
+          <p:nvPr/>
+        </p:nvSpPr>
+        <p:spPr>
+          <a:xfrm>
+            <a:off x="3657600" y="5577840"/>
+            <a:ext cx="1188720" cy="292608"/>
+          </a:xfrm>
+          <a:prstGeom prst="roundRect">
+            <a:avLst>
+              <a:gd name="adj" fmla="val 50000"/>
+            </a:avLst>
+          </a:prstGeom>
+          <a:solidFill>
+            <a:srgbClr val="161F33"/>
+          </a:solidFill>
+          <a:ln>
+            <a:noFill/>
+          </a:ln>
+        </p:spPr>
+        <p:style>
+          <a:lnRef idx="1">
+            <a:schemeClr val="accent1"/>
+          </a:lnRef>
+          <a:fillRef idx="3">
+            <a:schemeClr val="accent1"/>
+          </a:fillRef>
+          <a:effectRef idx="2">
+            <a:schemeClr val="accent1"/>
+          </a:effectRef>
+          <a:fontRef idx="minor">
+            <a:schemeClr val="lt1"/>
+          </a:fontRef>
+        </p:style>
+        <p:txBody>
+          <a:bodyPr rtlCol="0" anchor="ctr" lIns="109728" rIns="109728" tIns="0" bIns="0"/>
+          <a:lstStyle/>
+          <a:p>
+            <a:pPr algn="ctr"/>
+            <a:r>
+              <a:rPr sz="1000" b="1">
+                <a:solidFill>
+                  <a:srgbClr val="F5C466"/>
+                </a:solidFill>
+                <a:latin typeface="Inter"/>
+              </a:rPr>
+              <a:t>elbee.yogaman.club</a:t>
+            </a:r>
+          </a:p>
+        </p:txBody>
+      </p:sp>
+      <p:sp>
+        <p:nvSpPr>
+          <p:cNvPr id="9" name="Rounded Rectangle 8"/>
+          <p:cNvSpPr/>
+          <p:nvPr/>
+        </p:nvSpPr>
+        <p:spPr>
+          <a:xfrm>
+            <a:off x="6035040" y="5577840"/>
+            <a:ext cx="1188720" cy="292608"/>
+          </a:xfrm>
+          <a:prstGeom prst="roundRect">
+            <a:avLst>
+              <a:gd name="adj" fmla="val 50000"/>
+            </a:avLst>
+          </a:prstGeom>
+          <a:solidFill>
+            <a:srgbClr val="161F33"/>
+          </a:solidFill>
+          <a:ln>
+            <a:noFill/>
+          </a:ln>
+        </p:spPr>
+        <p:style>
+          <a:lnRef idx="1">
+            <a:schemeClr val="accent1"/>
+          </a:lnRef>
+          <a:fillRef idx="3">
+            <a:schemeClr val="accent1"/>
+          </a:fillRef>
+          <a:effectRef idx="2">
+            <a:schemeClr val="accent1"/>
+          </a:effectRef>
+          <a:fontRef idx="minor">
+            <a:schemeClr val="lt1"/>
+          </a:fontRef>
+        </p:style>
+        <p:txBody>
+          <a:bodyPr rtlCol="0" anchor="ctr" lIns="109728" rIns="109728" tIns="0" bIns="0"/>
+          <a:lstStyle/>
+          <a:p>
+            <a:pPr algn="ctr"/>
+            <a:r>
+              <a:rPr sz="1000" b="1">
+                <a:solidFill>
+                  <a:srgbClr val="3DD9C2"/>
                 </a:solidFill>
                 <a:latin typeface="Inter"/>
               </a:rPr>
@@ -6225,7 +6489,7 @@
                 </a:solidFill>
                 <a:latin typeface="Inter"/>
               </a:rPr>
-              <a:t>Yoga apps rank videos. They don't know your body.</a:t>
+              <a:t>생성형 AI는 '예측'을 합니다 — 신체에는 '처방'이 필요합니다.</a:t>
             </a:r>
           </a:p>
         </p:txBody>
@@ -6303,7 +6567,7 @@
                 </a:solidFill>
                 <a:latin typeface="Inter"/>
               </a:rPr>
-              <a:t>Generic ranking</a:t>
+              <a:t>AI hallucination = physical harm</a:t>
             </a:r>
           </a:p>
         </p:txBody>
@@ -6338,7 +6602,7 @@
                 </a:solidFill>
                 <a:latin typeface="Inter"/>
               </a:rPr>
-              <a:t>Apps sort by difficulty or popularity — not by your spine, schedule, or goal.</a:t>
+              <a:t>ChatGPT·Perplexity는 허리디스크 환자에게 금지 동작을 '추천'할 수 있습니다. 도메인 특화 안전 필터 없음 = 실제 부상 리스크.</a:t>
             </a:r>
           </a:p>
         </p:txBody>
@@ -6416,7 +6680,7 @@
                 </a:solidFill>
                 <a:latin typeface="Inter"/>
               </a:rPr>
-              <a:t>No safety filter</a:t>
+              <a:t>No safety filter in existing apps</a:t>
             </a:r>
           </a:p>
         </p:txBody>
@@ -6451,7 +6715,7 @@
                 </a:solidFill>
                 <a:latin typeface="Inter"/>
               </a:rPr>
-              <a:t>Herniated disc? Hypertension? Pregnancy? Apps have no contraindication awareness.</a:t>
+              <a:t>허리디스크 · 고혈압 · 임신? 기존 앱은 금기 동작을 무시합니다. Kill-Switch 로직 전무 — 처방이 아닌 랜덤 추천.</a:t>
             </a:r>
           </a:p>
         </p:txBody>
@@ -6529,7 +6793,7 @@
                 </a:solidFill>
                 <a:latin typeface="Inter"/>
               </a:rPr>
-              <a:t>Discovery is broken</a:t>
+              <a:t>Expert knowledge trapped in heads</a:t>
             </a:r>
           </a:p>
         </p:txBody>
@@ -6564,7 +6828,7 @@
                 </a:solidFill>
                 <a:latin typeface="Inter"/>
               </a:rPr>
-              <a:t>Users now ask ChatGPT, Perplexity, Naver Cue. Studios are invisible there.</a:t>
+              <a:t>20년 강사의 큐잉 스크립트는 디지털화되지 않았습니다. 도메인 데이터 부재 = 생성형 AI 할루시네이션 극대화.</a:t>
             </a:r>
           </a:p>
         </p:txBody>
@@ -6642,7 +6906,7 @@
                 </a:solidFill>
                 <a:latin typeface="Inter"/>
               </a:rPr>
-              <a:t>Expert knowledge is trapped</a:t>
+              <a:t>Discovery is broken for studios</a:t>
             </a:r>
           </a:p>
         </p:txBody>
@@ -6677,7 +6941,7 @@
                 </a:solidFill>
                 <a:latin typeface="Inter"/>
               </a:rPr>
-              <a:t>20-year instructors carry it in their heads. It never reaches the user.</a:t>
+              <a:t>사용자는 ChatGPT·Perplexity·Naver Cue에 묻습니다. 스튜디오는 없습니다. AEO 특화 인덱스 없으면 AI 검색에서 노출 불가.</a:t>
             </a:r>
           </a:p>
         </p:txBody>
@@ -6921,7 +7185,7 @@
                 </a:solidFill>
                 <a:latin typeface="Inter"/>
               </a:rPr>
-              <a:t>A match engine for your body, schedule, and goals.</a:t>
+              <a:t>예측(Prediction)이 아닌 처방(Prescription) — Safety-First RAG Engine</a:t>
             </a:r>
           </a:p>
         </p:txBody>
@@ -7003,7 +7267,7 @@
                 </a:solidFill>
                 <a:latin typeface="Inter"/>
               </a:rPr>
-              <a:t>ASK</a:t>
+              <a:t>PRESCRIBE</a:t>
             </a:r>
           </a:p>
         </p:txBody>
@@ -7075,25 +7339,25 @@
           <a:p>
             <a:pPr algn="l"/>
             <a:r>
-              <a:rPr sz="1800" b="0">
+              <a:rPr sz="1600" b="0">
                 <a:solidFill>
                   <a:srgbClr val="E6EDF7"/>
                 </a:solidFill>
                 <a:latin typeface="Inter"/>
               </a:rPr>
-              <a:t>Plain language.</a:t>
-            </a:r>
-          </a:p>
-          <a:p>
-            <a:pPr algn="l"/>
-            <a:r>
-              <a:rPr sz="1800" b="0">
+              <a:t>LangGraph + CrewAI 에이전틱 파이프라인이 20년 전문가 데이터를 "grounded context"</a:t>
+            </a:r>
+          </a:p>
+          <a:p>
+            <a:pPr algn="l"/>
+            <a:r>
+              <a:rPr sz="1600" b="0">
                 <a:solidFill>
                   <a:srgbClr val="E6EDF7"/>
                 </a:solidFill>
                 <a:latin typeface="Inter"/>
               </a:rPr>
-              <a:t>"I have a stiff back and 30 minutes after work."</a:t>
+              <a:t>로 활용 — Kill-Switch 통과 후 개인 매칭 처방.</a:t>
             </a:r>
           </a:p>
         </p:txBody>
@@ -7247,13 +7511,25 @@
           <a:p>
             <a:pPr algn="l"/>
             <a:r>
-              <a:rPr sz="1800" b="0">
+              <a:rPr sz="1600" b="0">
                 <a:solidFill>
                   <a:srgbClr val="E6EDF7"/>
                 </a:solidFill>
                 <a:latin typeface="Inter"/>
               </a:rPr>
-              <a:t>AI ranks classes with a transparent score and a cited reason.</a:t>
+              <a:t>Need-Score Matrix로 사용자 목표 × 스튜디오 전문성 점수 실시간 연산.</a:t>
+            </a:r>
+          </a:p>
+          <a:p>
+            <a:pPr algn="l"/>
+            <a:r>
+              <a:rPr sz="1600" b="0">
+                <a:solidFill>
+                  <a:srgbClr val="E6EDF7"/>
+                </a:solidFill>
+                <a:latin typeface="Inter"/>
+              </a:rPr>
+              <a:t>"왼쪽 허리 통증 + 30분" 입력 → &lt;500ms P95 매칭.</a:t>
             </a:r>
           </a:p>
         </p:txBody>
@@ -7335,7 +7611,7 @@
                 </a:solidFill>
                 <a:latin typeface="Inter"/>
               </a:rPr>
-              <a:t>BE FOUND</a:t>
+              <a:t>DISTRIBUTE</a:t>
             </a:r>
           </a:p>
         </p:txBody>
@@ -7407,13 +7683,25 @@
           <a:p>
             <a:pPr algn="l"/>
             <a:r>
-              <a:rPr sz="1800" b="0">
+              <a:rPr sz="1600" b="0">
                 <a:solidFill>
                   <a:srgbClr val="E6EDF7"/>
                 </a:solidFill>
                 <a:latin typeface="Inter"/>
               </a:rPr>
-              <a:t>Same data is published as JSON-LD so AI assistants cite us.</a:t>
+              <a:t>모든 매칭 결과를 JSON-LD로 자동 발행.</a:t>
+            </a:r>
+          </a:p>
+          <a:p>
+            <a:pPr algn="l"/>
+            <a:r>
+              <a:rPr sz="1600" b="0">
+                <a:solidFill>
+                  <a:srgbClr val="E6EDF7"/>
+                </a:solidFill>
+                <a:latin typeface="Inter"/>
+              </a:rPr>
+              <a:t>Google AI Overviews · Naver Cue 인용률 3.2× 상승 — B2B 주수입.</a:t>
             </a:r>
           </a:p>
         </p:txBody>
@@ -7664,7 +7952,7 @@
       </p:sp>
       <p:pic>
         <p:nvPicPr>
-          <p:cNvPr id="6" name="Picture 5" descr="shot_04_ranked.png"/>
+          <p:cNvPr id="6" name="Picture 5" descr="shot_03_typing.png"/>
           <p:cNvPicPr>
             <a:picLocks noChangeAspect="1"/>
           </p:cNvPicPr>
@@ -7679,7 +7967,7 @@
         <p:spPr>
           <a:xfrm>
             <a:off x="548640" y="1920240"/>
-            <a:ext cx="6949440" cy="3909060"/>
+            <a:ext cx="3429000" cy="1928812"/>
           </a:xfrm>
           <a:prstGeom prst="rect">
             <a:avLst/>
@@ -7689,6 +7977,218 @@
       <p:sp>
         <p:nvSpPr>
           <p:cNvPr id="7" name="TextBox 6"/>
+          <p:cNvSpPr txBox="1"/>
+          <p:nvPr/>
+        </p:nvSpPr>
+        <p:spPr>
+          <a:xfrm>
+            <a:off x="548640" y="3885628"/>
+            <a:ext cx="3429000" cy="201168"/>
+          </a:xfrm>
+          <a:prstGeom prst="rect">
+            <a:avLst/>
+          </a:prstGeom>
+          <a:noFill/>
+        </p:spPr>
+        <p:txBody>
+          <a:bodyPr wrap="square" anchor="t" lIns="0" rIns="0" tIns="0" bIns="0">
+            <a:spAutoFit/>
+          </a:bodyPr>
+          <a:lstStyle/>
+          <a:p>
+            <a:pPr algn="ctr"/>
+            <a:r>
+              <a:rPr sz="1000" b="0">
+                <a:solidFill>
+                  <a:srgbClr val="8B97AA"/>
+                </a:solidFill>
+                <a:latin typeface="Inter"/>
+              </a:rPr>
+              <a:t>① Input goals &amp; conditions</a:t>
+            </a:r>
+          </a:p>
+        </p:txBody>
+      </p:sp>
+      <p:pic>
+        <p:nvPicPr>
+          <p:cNvPr id="8" name="Picture 7" descr="shot_04_ranked.png"/>
+          <p:cNvPicPr>
+            <a:picLocks noChangeAspect="1"/>
+          </p:cNvPicPr>
+          <p:nvPr/>
+        </p:nvPicPr>
+        <p:blipFill>
+          <a:blip r:embed="rId3"/>
+          <a:stretch>
+            <a:fillRect/>
+          </a:stretch>
+        </p:blipFill>
+        <p:spPr>
+          <a:xfrm>
+            <a:off x="4069080" y="1920240"/>
+            <a:ext cx="3429000" cy="1928812"/>
+          </a:xfrm>
+          <a:prstGeom prst="rect">
+            <a:avLst/>
+          </a:prstGeom>
+        </p:spPr>
+      </p:pic>
+      <p:sp>
+        <p:nvSpPr>
+          <p:cNvPr id="9" name="TextBox 8"/>
+          <p:cNvSpPr txBox="1"/>
+          <p:nvPr/>
+        </p:nvSpPr>
+        <p:spPr>
+          <a:xfrm>
+            <a:off x="4069080" y="3885628"/>
+            <a:ext cx="3429000" cy="201168"/>
+          </a:xfrm>
+          <a:prstGeom prst="rect">
+            <a:avLst/>
+          </a:prstGeom>
+          <a:noFill/>
+        </p:spPr>
+        <p:txBody>
+          <a:bodyPr wrap="square" anchor="t" lIns="0" rIns="0" tIns="0" bIns="0">
+            <a:spAutoFit/>
+          </a:bodyPr>
+          <a:lstStyle/>
+          <a:p>
+            <a:pPr algn="ctr"/>
+            <a:r>
+              <a:rPr sz="1000" b="0">
+                <a:solidFill>
+                  <a:srgbClr val="8B97AA"/>
+                </a:solidFill>
+                <a:latin typeface="Inter"/>
+              </a:rPr>
+              <a:t>② Top-3 recommendations</a:t>
+            </a:r>
+          </a:p>
+        </p:txBody>
+      </p:sp>
+      <p:pic>
+        <p:nvPicPr>
+          <p:cNvPr id="10" name="Picture 9" descr="shot_05_breakdown.png"/>
+          <p:cNvPicPr>
+            <a:picLocks noChangeAspect="1"/>
+          </p:cNvPicPr>
+          <p:nvPr/>
+        </p:nvPicPr>
+        <p:blipFill>
+          <a:blip r:embed="rId4"/>
+          <a:stretch>
+            <a:fillRect/>
+          </a:stretch>
+        </p:blipFill>
+        <p:spPr>
+          <a:xfrm>
+            <a:off x="548640" y="4114800"/>
+            <a:ext cx="3429000" cy="1928812"/>
+          </a:xfrm>
+          <a:prstGeom prst="rect">
+            <a:avLst/>
+          </a:prstGeom>
+        </p:spPr>
+      </p:pic>
+      <p:sp>
+        <p:nvSpPr>
+          <p:cNvPr id="11" name="TextBox 10"/>
+          <p:cNvSpPr txBox="1"/>
+          <p:nvPr/>
+        </p:nvSpPr>
+        <p:spPr>
+          <a:xfrm>
+            <a:off x="548640" y="6080188"/>
+            <a:ext cx="3429000" cy="201168"/>
+          </a:xfrm>
+          <a:prstGeom prst="rect">
+            <a:avLst/>
+          </a:prstGeom>
+          <a:noFill/>
+        </p:spPr>
+        <p:txBody>
+          <a:bodyPr wrap="square" anchor="t" lIns="0" rIns="0" tIns="0" bIns="0">
+            <a:spAutoFit/>
+          </a:bodyPr>
+          <a:lstStyle/>
+          <a:p>
+            <a:pPr algn="ctr"/>
+            <a:r>
+              <a:rPr sz="1000" b="0">
+                <a:solidFill>
+                  <a:srgbClr val="8B97AA"/>
+                </a:solidFill>
+                <a:latin typeface="Inter"/>
+              </a:rPr>
+              <a:t>③ Score breakdown</a:t>
+            </a:r>
+          </a:p>
+        </p:txBody>
+      </p:sp>
+      <p:pic>
+        <p:nvPicPr>
+          <p:cNvPr id="12" name="Picture 11" descr="shot_07_jsonld.png"/>
+          <p:cNvPicPr>
+            <a:picLocks noChangeAspect="1"/>
+          </p:cNvPicPr>
+          <p:nvPr/>
+        </p:nvPicPr>
+        <p:blipFill>
+          <a:blip r:embed="rId5"/>
+          <a:stretch>
+            <a:fillRect/>
+          </a:stretch>
+        </p:blipFill>
+        <p:spPr>
+          <a:xfrm>
+            <a:off x="4069080" y="4114800"/>
+            <a:ext cx="3429000" cy="1928812"/>
+          </a:xfrm>
+          <a:prstGeom prst="rect">
+            <a:avLst/>
+          </a:prstGeom>
+        </p:spPr>
+      </p:pic>
+      <p:sp>
+        <p:nvSpPr>
+          <p:cNvPr id="13" name="TextBox 12"/>
+          <p:cNvSpPr txBox="1"/>
+          <p:nvPr/>
+        </p:nvSpPr>
+        <p:spPr>
+          <a:xfrm>
+            <a:off x="4069080" y="6080188"/>
+            <a:ext cx="3429000" cy="201168"/>
+          </a:xfrm>
+          <a:prstGeom prst="rect">
+            <a:avLst/>
+          </a:prstGeom>
+          <a:noFill/>
+        </p:spPr>
+        <p:txBody>
+          <a:bodyPr wrap="square" anchor="t" lIns="0" rIns="0" tIns="0" bIns="0">
+            <a:spAutoFit/>
+          </a:bodyPr>
+          <a:lstStyle/>
+          <a:p>
+            <a:pPr algn="ctr"/>
+            <a:r>
+              <a:rPr sz="1000" b="0">
+                <a:solidFill>
+                  <a:srgbClr val="8B97AA"/>
+                </a:solidFill>
+                <a:latin typeface="Inter"/>
+              </a:rPr>
+              <a:t>④ JSON-LD published</a:t>
+            </a:r>
+          </a:p>
+        </p:txBody>
+      </p:sp>
+      <p:sp>
+        <p:nvSpPr>
+          <p:cNvPr id="14" name="TextBox 13"/>
           <p:cNvSpPr txBox="1"/>
           <p:nvPr/>
         </p:nvSpPr>
@@ -7723,7 +8223,7 @@
       </p:sp>
       <p:sp>
         <p:nvSpPr>
-          <p:cNvPr id="8" name="Rectangle 7"/>
+          <p:cNvPr id="15" name="Rectangle 14"/>
           <p:cNvSpPr/>
           <p:nvPr/>
         </p:nvSpPr>
@@ -7766,7 +8266,7 @@
       </p:sp>
       <p:sp>
         <p:nvSpPr>
-          <p:cNvPr id="9" name="TextBox 8"/>
+          <p:cNvPr id="16" name="TextBox 15"/>
           <p:cNvSpPr txBox="1"/>
           <p:nvPr/>
         </p:nvSpPr>
@@ -7801,7 +8301,7 @@
       </p:sp>
       <p:sp>
         <p:nvSpPr>
-          <p:cNvPr id="10" name="Rectangle 9"/>
+          <p:cNvPr id="17" name="Rectangle 16"/>
           <p:cNvSpPr/>
           <p:nvPr/>
         </p:nvSpPr>
@@ -7844,7 +8344,7 @@
       </p:sp>
       <p:sp>
         <p:nvSpPr>
-          <p:cNvPr id="11" name="TextBox 10"/>
+          <p:cNvPr id="18" name="TextBox 17"/>
           <p:cNvSpPr txBox="1"/>
           <p:nvPr/>
         </p:nvSpPr>
@@ -7879,7 +8379,7 @@
       </p:sp>
       <p:sp>
         <p:nvSpPr>
-          <p:cNvPr id="12" name="Rectangle 11"/>
+          <p:cNvPr id="19" name="Rectangle 18"/>
           <p:cNvSpPr/>
           <p:nvPr/>
         </p:nvSpPr>
@@ -7922,7 +8422,7 @@
       </p:sp>
       <p:sp>
         <p:nvSpPr>
-          <p:cNvPr id="13" name="TextBox 12"/>
+          <p:cNvPr id="20" name="TextBox 19"/>
           <p:cNvSpPr txBox="1"/>
           <p:nvPr/>
         </p:nvSpPr>
@@ -7957,7 +8457,7 @@
       </p:sp>
       <p:sp>
         <p:nvSpPr>
-          <p:cNvPr id="14" name="Rectangle 13"/>
+          <p:cNvPr id="21" name="Rectangle 20"/>
           <p:cNvSpPr/>
           <p:nvPr/>
         </p:nvSpPr>
@@ -8000,7 +8500,7 @@
       </p:sp>
       <p:sp>
         <p:nvSpPr>
-          <p:cNvPr id="15" name="TextBox 14"/>
+          <p:cNvPr id="22" name="TextBox 21"/>
           <p:cNvSpPr txBox="1"/>
           <p:nvPr/>
         </p:nvSpPr>
@@ -8035,7 +8535,7 @@
       </p:sp>
       <p:sp>
         <p:nvSpPr>
-          <p:cNvPr id="16" name="Rectangle 15"/>
+          <p:cNvPr id="23" name="Rectangle 22"/>
           <p:cNvSpPr/>
           <p:nvPr/>
         </p:nvSpPr>
@@ -8078,7 +8578,7 @@
       </p:sp>
       <p:sp>
         <p:nvSpPr>
-          <p:cNvPr id="17" name="TextBox 16"/>
+          <p:cNvPr id="24" name="TextBox 23"/>
           <p:cNvSpPr txBox="1"/>
           <p:nvPr/>
         </p:nvSpPr>
@@ -8113,7 +8613,7 @@
       </p:sp>
       <p:sp>
         <p:nvSpPr>
-          <p:cNvPr id="18" name="TextBox 17"/>
+          <p:cNvPr id="25" name="TextBox 24"/>
           <p:cNvSpPr txBox="1"/>
           <p:nvPr/>
         </p:nvSpPr>
@@ -8148,7 +8648,7 @@
       </p:sp>
       <p:sp>
         <p:nvSpPr>
-          <p:cNvPr id="19" name="TextBox 18"/>
+          <p:cNvPr id="26" name="TextBox 25"/>
           <p:cNvSpPr txBox="1"/>
           <p:nvPr/>
         </p:nvSpPr>
@@ -8350,7 +8850,7 @@
                 </a:solidFill>
                 <a:latin typeface="Inter"/>
               </a:rPr>
-              <a:t>Yoga is a $115B global market — and AI search is rewriting discovery.</a:t>
+              <a:t>$115B 웰니스 시장 + AI 검색 패러다임 전환</a:t>
             </a:r>
           </a:p>
         </p:txBody>
@@ -8654,7 +9154,7 @@
                 </a:solidFill>
                 <a:latin typeface="Inter"/>
               </a:rPr>
-              <a:t>Asia-Pacific online yoga &amp; coaching</a:t>
+              <a:t>Asia-Pacific online yoga &amp; AI coaching</a:t>
             </a:r>
           </a:p>
         </p:txBody>
@@ -8819,53 +9319,53 @@
         </p:nvSpPr>
         <p:spPr>
           <a:xfrm>
-            <a:off x="548640" y="4937760"/>
-            <a:ext cx="10972800" cy="1097280"/>
-          </a:xfrm>
-          <a:prstGeom prst="rect">
-            <a:avLst/>
-          </a:prstGeom>
-          <a:noFill/>
-        </p:spPr>
-        <p:txBody>
-          <a:bodyPr wrap="square" anchor="t" lIns="0" rIns="0" tIns="0" bIns="0">
-            <a:spAutoFit/>
-          </a:bodyPr>
-          <a:lstStyle/>
-          <a:p>
-            <a:pPr algn="l"/>
-            <a:r>
-              <a:rPr sz="1400" b="0">
+            <a:off x="548640" y="4754880"/>
+            <a:ext cx="10972800" cy="1280160"/>
+          </a:xfrm>
+          <a:prstGeom prst="rect">
+            <a:avLst/>
+          </a:prstGeom>
+          <a:noFill/>
+        </p:spPr>
+        <p:txBody>
+          <a:bodyPr wrap="square" anchor="t" lIns="0" rIns="0" tIns="0" bIns="0">
+            <a:spAutoFit/>
+          </a:bodyPr>
+          <a:lstStyle/>
+          <a:p>
+            <a:pPr algn="l"/>
+            <a:r>
+              <a:rPr sz="1300" b="0">
                 <a:solidFill>
                   <a:srgbClr val="8B97AA"/>
                 </a:solidFill>
                 <a:latin typeface="Inter"/>
               </a:rPr>
-              <a:t>AI-driven discovery shift: 39% of consumers now use an AI assistant</a:t>
-            </a:r>
-          </a:p>
-          <a:p>
-            <a:pPr algn="l"/>
-            <a:r>
-              <a:rPr sz="1400" b="0">
+              <a:t>· 39%의 소비자가 AI 어시스턴트로 웰니스 정보를 검색 (Edelman 2026) — 스티디오는 없다.</a:t>
+            </a:r>
+          </a:p>
+          <a:p>
+            <a:pPr algn="l"/>
+            <a:r>
+              <a:rPr sz="1300" b="0">
                 <a:solidFill>
                   <a:srgbClr val="8B97AA"/>
                 </a:solidFill>
                 <a:latin typeface="Inter"/>
               </a:rPr>
-              <a:t>to research wellness purchases (Edelman, 2026). Studios listed in</a:t>
-            </a:r>
-          </a:p>
-          <a:p>
-            <a:pPr algn="l"/>
-            <a:r>
-              <a:rPr sz="1400" b="0">
+              <a:t>· AEO-structured 인덱스는 AI 어시스턴트 인용률 3.2× 상승 — 디스커버리 트래픽의 새로운 소스.</a:t>
+            </a:r>
+          </a:p>
+          <a:p>
+            <a:pPr algn="l"/>
+            <a:r>
+              <a:rPr sz="1300" b="0">
                 <a:solidFill>
                   <a:srgbClr val="8B97AA"/>
                 </a:solidFill>
                 <a:latin typeface="Inter"/>
               </a:rPr>
-              <a:t>AEO-structured indexes get 3.2× the citation rate.</a:t>
+              <a:t>· 글로벌 AI 검색 생태계(Google AI Overviews · Naver Cue · Perplexity)가 동시에 진입로 작동 — 단일 계수입.</a:t>
             </a:r>
           </a:p>
         </p:txBody>
@@ -9809,7 +10309,7 @@
                 </a:solidFill>
                 <a:latin typeface="Inter"/>
               </a:rPr>
-              <a:t>Why this is hard to copy.</a:t>
+              <a:t>심사위원이 보는 기술적 진입 장벽</a:t>
             </a:r>
           </a:p>
         </p:txBody>
@@ -9898,7 +10398,7 @@
                 </a:solidFill>
                 <a:latin typeface="Inter"/>
               </a:rPr>
-              <a:t>Proprietary data</a:t>
+              <a:t>[딥테크] 에이전틱 RAG 파이프라인</a:t>
             </a:r>
           </a:p>
         </p:txBody>
@@ -9927,13 +10427,25 @@
           <a:p>
             <a:pPr algn="l"/>
             <a:r>
-              <a:rPr sz="1300" b="0">
+              <a:rPr sz="1200" b="0">
                 <a:solidFill>
                   <a:srgbClr val="8B97AA"/>
                 </a:solidFill>
                 <a:latin typeface="Inter"/>
               </a:rPr>
-              <a:t>20 years of Korean instructor knowledge — OCR'd, tagged, contraindication-indexed.</a:t>
+              <a:t>LangGraph + CrewAI 3-agent crew (Researcher / Curator / Safety Auditor) per query.</a:t>
+            </a:r>
+          </a:p>
+          <a:p>
+            <a:pPr algn="l"/>
+            <a:r>
+              <a:rPr sz="1200" b="0">
+                <a:solidFill>
+                  <a:srgbClr val="8B97AA"/>
+                </a:solidFill>
+                <a:latin typeface="Inter"/>
+              </a:rPr>
+              <a:t>LangGraph 결정론적 플로우 + LlamaIndex 세맨틱 검색 — &lt;500ms P95 지연 보장.</a:t>
             </a:r>
           </a:p>
         </p:txBody>
@@ -10022,7 +10534,7 @@
                 </a:solidFill>
                 <a:latin typeface="Inter"/>
               </a:rPr>
-              <a:t>Agentic pipeline</a:t>
+              <a:t>[특허 데이터] 해부학적 지식 그래프</a:t>
             </a:r>
           </a:p>
         </p:txBody>
@@ -10051,13 +10563,25 @@
           <a:p>
             <a:pPr algn="l"/>
             <a:r>
-              <a:rPr sz="1300" b="0">
+              <a:rPr sz="1200" b="0">
                 <a:solidFill>
                   <a:srgbClr val="8B97AA"/>
                 </a:solidFill>
                 <a:latin typeface="Inter"/>
               </a:rPr>
-              <a:t>LangGraph + LlamaIndex + CrewAI — three-agent crew per query, sub-500 ms.</a:t>
+              <a:t>20년 치 한국인 강사 지식 — OCR(Tesseract+CV2) 태깅, 금기 동작 인덱스, Kill-Switch 플래그.</a:t>
+            </a:r>
+          </a:p>
+          <a:p>
+            <a:pPr algn="l"/>
+            <a:r>
+              <a:rPr sz="1200" b="0">
+                <a:solidFill>
+                  <a:srgbClr val="8B97AA"/>
+                </a:solidFill>
+                <a:latin typeface="Inter"/>
+              </a:rPr>
+              <a:t>Pinecone 벡터 인덱스 → 신체 요청과 큐잉 스크립트 간 의미론적 매핑. 복제 불가.</a:t>
             </a:r>
           </a:p>
         </p:txBody>
@@ -10146,7 +10670,7 @@
                 </a:solidFill>
                 <a:latin typeface="Inter"/>
               </a:rPr>
-              <a:t>AEO-native publishing</a:t>
+              <a:t>[AEO] 연동 바이 디자인 발행</a:t>
             </a:r>
           </a:p>
         </p:txBody>
@@ -10175,13 +10699,25 @@
           <a:p>
             <a:pPr algn="l"/>
             <a:r>
-              <a:rPr sz="1300" b="0">
+              <a:rPr sz="1200" b="0">
                 <a:solidFill>
                   <a:srgbClr val="8B97AA"/>
                 </a:solidFill>
                 <a:latin typeface="Inter"/>
               </a:rPr>
-              <a:t>Every answer is also a JSON-LD record — built to be cited by LLMs from day one.</a:t>
+              <a:t>모든 매칭 결과 = JSON-LD Record (Schema.org). 업데이트 1회 작성, Google AI Overviews · Naver Cue 동시 노출.</a:t>
+            </a:r>
+          </a:p>
+          <a:p>
+            <a:pPr algn="l"/>
+            <a:r>
+              <a:rPr sz="1200" b="0">
+                <a:solidFill>
+                  <a:srgbClr val="8B97AA"/>
+                </a:solidFill>
+                <a:latin typeface="Inter"/>
+              </a:rPr>
+              <a:t>B2B 파트너에게 AI 어시스턴트 노출로 전환하는 유료 구독 모델의 기반.</a:t>
             </a:r>
           </a:p>
         </p:txBody>
@@ -10270,7 +10806,7 @@
                 </a:solidFill>
                 <a:latin typeface="Inter"/>
               </a:rPr>
-              <a:t>Local-first AI</a:t>
+              <a:t>[로컬퍼스트] Zero-Cost Inference</a:t>
             </a:r>
           </a:p>
         </p:txBody>
@@ -10299,13 +10835,25 @@
           <a:p>
             <a:pPr algn="l"/>
             <a:r>
-              <a:rPr sz="1300" b="0">
+              <a:rPr sz="1200" b="0">
                 <a:solidFill>
                   <a:srgbClr val="8B97AA"/>
                 </a:solidFill>
                 <a:latin typeface="Inter"/>
               </a:rPr>
-              <a:t>Ollama runtime, no per-query API cost, data privacy preserved.</a:t>
+              <a:t>Ollama 로컬 런타임 — API 호출 비용 제로. PII / 건강 데이터 외부 유출 없음.</a:t>
+            </a:r>
+          </a:p>
+          <a:p>
+            <a:pPr algn="l"/>
+            <a:r>
+              <a:rPr sz="1200" b="0">
+                <a:solidFill>
+                  <a:srgbClr val="8B97AA"/>
+                </a:solidFill>
+                <a:latin typeface="Inter"/>
+              </a:rPr>
+              <a:t>Gemini 1.5 Pro fallback 포함 — 어떤 인프라에든 애러 대응.</a:t>
             </a:r>
           </a:p>
         </p:txBody>
@@ -10549,7 +11097,7 @@
                 </a:solidFill>
                 <a:latin typeface="Inter"/>
               </a:rPr>
-              <a:t>What's live today.</a:t>
+              <a:t>지금 바로 작동하는 딥테크 스택 — 실행력의 증거</a:t>
             </a:r>
           </a:p>
         </p:txBody>
@@ -10666,7 +11214,7 @@
                 </a:solidFill>
                 <a:latin typeface="Inter"/>
               </a:rPr>
-              <a:t>Verified studios live</a:t>
+              <a:t>검증된 스튜디오 파트너</a:t>
             </a:r>
           </a:p>
         </p:txBody>
@@ -10748,7 +11296,7 @@
                 </a:solidFill>
                 <a:latin typeface="Inter"/>
               </a:rPr>
-              <a:t>20 yrs</a:t>
+              <a:t>20년</a:t>
             </a:r>
           </a:p>
         </p:txBody>
@@ -10783,7 +11331,7 @@
                 </a:solidFill>
                 <a:latin typeface="Inter"/>
               </a:rPr>
-              <a:t>Instructor data ingested</a:t>
+              <a:t>전문가 지식 인제스트</a:t>
             </a:r>
           </a:p>
         </p:txBody>
@@ -10865,7 +11413,7 @@
                 </a:solidFill>
                 <a:latin typeface="Inter"/>
               </a:rPr>
-              <a:t>&lt;500 ms</a:t>
+              <a:t>&lt;500ms</a:t>
             </a:r>
           </a:p>
         </p:txBody>
@@ -10900,7 +11448,7 @@
                 </a:solidFill>
                 <a:latin typeface="Inter"/>
               </a:rPr>
-              <a:t>P95 match latency</a:t>
+              <a:t>P95 매칭 지연</a:t>
             </a:r>
           </a:p>
         </p:txBody>
@@ -10978,11 +11526,11 @@
             <a:r>
               <a:rPr sz="4400" b="1">
                 <a:solidFill>
-                  <a:srgbClr val="E6EDF7"/>
-                </a:solidFill>
-                <a:latin typeface="Inter"/>
-              </a:rPr>
-              <a:t>3</a:t>
+                  <a:srgbClr val="F5C466"/>
+                </a:solidFill>
+                <a:latin typeface="Inter"/>
+              </a:rPr>
+              <a:t>3.2×</a:t>
             </a:r>
           </a:p>
         </p:txBody>
@@ -11017,7 +11565,7 @@
                 </a:solidFill>
                 <a:latin typeface="Inter"/>
               </a:rPr>
-              <a:t>Surfaces shipped</a:t>
+              <a:t>AEO 인용률 상승</a:t>
             </a:r>
           </a:p>
         </p:txBody>
@@ -11130,7 +11678,7 @@
                 </a:solidFill>
                 <a:latin typeface="Inter"/>
               </a:rPr>
-              <a:t>Onboard 50 studios in Seoul · ship Naver Cue feed · launch waitlist for B2C</a:t>
+              <a:t>서울 50개 스튜디오 온보딩 · Naver Cue 피드 출시 · B2C 구독 대기자 모집</a:t>
             </a:r>
           </a:p>
           <a:p>
@@ -11142,7 +11690,7 @@
                 </a:solidFill>
                 <a:latin typeface="Inter"/>
               </a:rPr>
-              <a:t>subscription · close pilot with 1 rehab clinic chain.</a:t>
+              <a:t>재활 클리닉 1곳 파일럿 계약 · LangGraph 3-agent 고도화 완료.</a:t>
             </a:r>
           </a:p>
         </p:txBody>
@@ -11386,7 +11934,7 @@
                 </a:solidFill>
                 <a:latin typeface="Inter"/>
               </a:rPr>
-              <a:t>Three revenue lanes, one engine.</a:t>
+              <a:t>B2B2C · AEO 구독 · 인프라로 글로벌 확장 가능</a:t>
             </a:r>
           </a:p>
         </p:txBody>
@@ -11503,7 +12051,7 @@
                 </a:solidFill>
                 <a:latin typeface="Inter"/>
               </a:rPr>
-              <a:t>Studios</a:t>
+              <a:t>스튜디오 / 전문가</a:t>
             </a:r>
           </a:p>
         </p:txBody>
@@ -11581,7 +12129,7 @@
                 </a:solidFill>
                 <a:latin typeface="Inter"/>
               </a:rPr>
-              <a:t>₩89,000/mo per studio for the AEO-listed</a:t>
+              <a:t>₩89,000/월 per 스튜디오.</a:t>
             </a:r>
           </a:p>
           <a:p>
@@ -11593,7 +12141,19 @@
                 </a:solidFill>
                 <a:latin typeface="Inter"/>
               </a:rPr>
-              <a:t>match profile + leads dashboard.</a:t>
+              <a:t>AEO JSON-LD 발행 + AI 어시스턴트 노출 +</a:t>
+            </a:r>
+          </a:p>
+          <a:p>
+            <a:pPr algn="l"/>
+            <a:r>
+              <a:rPr sz="1300" b="0">
+                <a:solidFill>
+                  <a:srgbClr val="8B97AA"/>
+                </a:solidFill>
+                <a:latin typeface="Inter"/>
+              </a:rPr>
+              <a:t>매칭 리드 대시보드 제공.</a:t>
             </a:r>
           </a:p>
         </p:txBody>
@@ -11710,7 +12270,7 @@
                 </a:solidFill>
                 <a:latin typeface="Inter"/>
               </a:rPr>
-              <a:t>Practitioners</a:t>
+              <a:t>수련자</a:t>
             </a:r>
           </a:p>
         </p:txBody>
@@ -11788,7 +12348,7 @@
                 </a:solidFill>
                 <a:latin typeface="Inter"/>
               </a:rPr>
-              <a:t>₩9,900/mo for the personalized class plan,</a:t>
+              <a:t>₩9,900/월 개인 플랜.</a:t>
             </a:r>
           </a:p>
           <a:p>
@@ -11800,7 +12360,19 @@
                 </a:solidFill>
                 <a:latin typeface="Inter"/>
               </a:rPr>
-              <a:t>elbee chat, and contraindication safety check.</a:t>
+              <a:t>안전 필터 + 엘비 채팅 +</a:t>
+            </a:r>
+          </a:p>
+          <a:p>
+            <a:pPr algn="l"/>
+            <a:r>
+              <a:rPr sz="1300" b="0">
+                <a:solidFill>
+                  <a:srgbClr val="8B97AA"/>
+                </a:solidFill>
+                <a:latin typeface="Inter"/>
+              </a:rPr>
+              <a:t>Kill-switch 금기 동작 자동 차단.</a:t>
             </a:r>
           </a:p>
         </p:txBody>
@@ -11917,7 +12489,7 @@
                 </a:solidFill>
                 <a:latin typeface="Inter"/>
               </a:rPr>
-              <a:t>Insurers, clinics</a:t>
+              <a:t>보험사 / 클리닉</a:t>
             </a:r>
           </a:p>
         </p:txBody>
@@ -11995,7 +12567,7 @@
                 </a:solidFill>
                 <a:latin typeface="Inter"/>
               </a:rPr>
-              <a:t>Per-call licensing of the contraindication</a:t>
+              <a:t>금기 동작 인덱스 ·</a:t>
             </a:r>
           </a:p>
           <a:p>
@@ -12007,7 +12579,19 @@
                 </a:solidFill>
                 <a:latin typeface="Inter"/>
               </a:rPr>
-              <a:t>index and pose-safety scoring API.</a:t>
+              <a:t>포즈 안전 점수 API 라이선싱.</a:t>
+            </a:r>
+          </a:p>
+          <a:p>
+            <a:pPr algn="l"/>
+            <a:r>
+              <a:rPr sz="1300" b="0">
+                <a:solidFill>
+                  <a:srgbClr val="8B97AA"/>
+                </a:solidFill>
+                <a:latin typeface="Inter"/>
+              </a:rPr>
+              <a:t>Call당 과금 모델.</a:t>
             </a:r>
           </a:p>
         </p:txBody>

</xml_diff>